<commit_message>
Actualiza informe, presentacion y README del Avance 2
- Informe: CRUD de clientes, normalizacion (seccion 5.4), 9 pruebas,
  34 endpoints y resultados de Postman.
- Presentacion: 34 endpoints, 9 pruebas, evidencias y pendientes.
- README: endpoints de clientes y como correr newman.
</commit_message>
<xml_diff>
--- a/docs/avance-2/Presentacion_Avance_2_CRM_Cobranzas.pptx
+++ b/docs/avance-2/Presentacion_Avance_2_CRM_Cobranzas.pptx
@@ -2127,7 +2127,7 @@
                 <a:ea typeface="Calibri" pitchFamily="34" charset="-122"/>
                 <a:cs typeface="Calibri" pitchFamily="34" charset="-120"/>
               </a:rPr>
-              <a:t>Workbench con las 12 tablas creadas por 01_esquema.sql</a:t>
+              <a:t>Reporte de Postman: 34 de 34 peticiones pasan (docs/avance-2)</a:t>
             </a:r>
             <a:endParaRPr lang="en-US" sz="1700" dirty="0"/>
           </a:p>
@@ -2148,7 +2148,7 @@
                 <a:ea typeface="Calibri" pitchFamily="34" charset="-122"/>
                 <a:cs typeface="Calibri" pitchFamily="34" charset="-120"/>
               </a:rPr>
-              <a:t>Postman: casos P01–P04 y una carga CSV con aceptados y rechazados</a:t>
+              <a:t>Captura de ./mvnw test con 9 de 9 pruebas</a:t>
             </a:r>
             <a:endParaRPr lang="en-US" sz="1700" dirty="0"/>
           </a:p>
@@ -2169,7 +2169,7 @@
                 <a:ea typeface="Calibri" pitchFamily="34" charset="-122"/>
                 <a:cs typeface="Calibri" pitchFamily="34" charset="-120"/>
               </a:rPr>
-              <a:t>Captura de ./mvnw test con BUILD SUCCESS</a:t>
+              <a:t>Workbench con las 12 tablas en MySQL 8 real (pendiente)</a:t>
             </a:r>
             <a:endParaRPr lang="en-US" sz="1700" dirty="0"/>
           </a:p>
@@ -2321,6 +2321,27 @@
                 <a:cs typeface="Calibri" pitchFamily="34" charset="-120"/>
               </a:rPr>
               <a:t>Secretos fuera del código: variables de entorno</a:t>
+            </a:r>
+            <a:endParaRPr lang="en-US" sz="1700" dirty="0"/>
+          </a:p>
+          <a:p>
+            <a:pPr marL="342900" indent="-342900">
+              <a:spcAft>
+                <a:spcPts val="1200"/>
+              </a:spcAft>
+              <a:buSzPct val="100000"/>
+              <a:buChar char="•"/>
+            </a:pPr>
+            <a:r>
+              <a:rPr lang="en-US" sz="1700" dirty="0">
+                <a:solidFill>
+                  <a:srgbClr val="111827"/>
+                </a:solidFill>
+                <a:latin typeface="Calibri" pitchFamily="34" charset="0"/>
+                <a:ea typeface="Calibri" pitchFamily="34" charset="-122"/>
+                <a:cs typeface="Calibri" pitchFamily="34" charset="-120"/>
+              </a:rPr>
+              <a:t>Ejecutar el backend en MySQL 8 real</a:t>
             </a:r>
             <a:endParaRPr lang="en-US" sz="1700" dirty="0"/>
           </a:p>
@@ -3468,7 +3489,7 @@
                 <a:ea typeface="Calibri" pitchFamily="34" charset="-122"/>
                 <a:cs typeface="Calibri" pitchFamily="34" charset="-120"/>
               </a:rPr>
-              <a:t>31 endpoints</a:t>
+              <a:t>34 endpoints</a:t>
             </a:r>
             <a:endParaRPr lang="en-US" sz="1600" dirty="0"/>
           </a:p>
@@ -5167,7 +5188,7 @@
                 <a:ea typeface="Calibri" pitchFamily="34" charset="-122"/>
                 <a:cs typeface="Calibri" pitchFamily="34" charset="-120"/>
               </a:rPr>
-              <a:t>31 endpoints: 16 GET · 8 POST · 3 PUT · 2 PATCH · 2 DELETE</a:t>
+              <a:t>34 endpoints: 16 GET · 9 POST · 4 PUT · 2 PATCH · 3 DELETE</a:t>
             </a:r>
             <a:endParaRPr lang="en-US" sz="1600" dirty="0"/>
           </a:p>
@@ -5201,7 +5222,7 @@
                 <a:gridCol w="2926080"/>
                 <a:gridCol w="2834640"/>
               </a:tblGrid>
-              <a:tr h="566928">
+              <a:tr h="512064">
                 <a:tc>
                   <a:txBody>
                     <a:bodyPr/>
@@ -5475,7 +5496,7 @@
                   </a:tcPr>
                 </a:tc>
               </a:tr>
-              <a:tr h="566928">
+              <a:tr h="512064">
                 <a:tc>
                   <a:txBody>
                     <a:bodyPr/>
@@ -5737,7 +5758,7 @@
                   </a:tcPr>
                 </a:tc>
               </a:tr>
-              <a:tr h="566928">
+              <a:tr h="512064">
                 <a:tc>
                   <a:txBody>
                     <a:bodyPr/>
@@ -5999,7 +6020,269 @@
                   </a:tcPr>
                 </a:tc>
               </a:tr>
-              <a:tr h="566928">
+              <a:tr h="512064">
+                <a:tc>
+                  <a:txBody>
+                    <a:bodyPr/>
+                    <a:lstStyle/>
+                    <a:p>
+                      <a:pPr indent="0" marL="0">
+                        <a:buNone/>
+                      </a:pPr>
+                      <a:r>
+                        <a:rPr lang="en-US" sz="1500" dirty="0">
+                          <a:solidFill>
+                            <a:srgbClr val="111827"/>
+                          </a:solidFill>
+                          <a:latin typeface="Calibri" pitchFamily="34" charset="0"/>
+                          <a:ea typeface="Calibri" pitchFamily="34" charset="-122"/>
+                          <a:cs typeface="Calibri" pitchFamily="34" charset="-120"/>
+                        </a:rPr>
+                        <a:t>Cliente</a:t>
+                      </a:r>
+                      <a:endParaRPr lang="en-US" sz="1500" dirty="0">
+                        <a:latin typeface="Calibri" charset="0"/>
+                        <a:ea typeface="Calibri" charset="0"/>
+                        <a:cs typeface="Calibri" charset="0"/>
+                      </a:endParaRPr>
+                    </a:p>
+                  </a:txBody>
+                  <a:tcPr marL="109728" marR="109728" marT="54864" marB="54864" anchor="ctr">
+                    <a:lnL w="9525" cap="flat" cmpd="sng" algn="ctr">
+                      <a:solidFill>
+                        <a:srgbClr val="D1D5DB"/>
+                      </a:solidFill>
+                      <a:prstDash val="solid"/>
+                      <a:round/>
+                      <a:headEnd type="none" w="med" len="med"/>
+                      <a:tailEnd type="none" w="med" len="med"/>
+                    </a:lnL>
+                    <a:lnR w="9525" cap="flat" cmpd="sng" algn="ctr">
+                      <a:solidFill>
+                        <a:srgbClr val="D1D5DB"/>
+                      </a:solidFill>
+                      <a:prstDash val="solid"/>
+                      <a:round/>
+                      <a:headEnd type="none" w="med" len="med"/>
+                      <a:tailEnd type="none" w="med" len="med"/>
+                    </a:lnR>
+                    <a:lnT w="9525" cap="flat" cmpd="sng" algn="ctr">
+                      <a:solidFill>
+                        <a:srgbClr val="D1D5DB"/>
+                      </a:solidFill>
+                      <a:prstDash val="solid"/>
+                      <a:round/>
+                      <a:headEnd type="none" w="med" len="med"/>
+                      <a:tailEnd type="none" w="med" len="med"/>
+                    </a:lnT>
+                    <a:lnB w="9525" cap="flat" cmpd="sng" algn="ctr">
+                      <a:solidFill>
+                        <a:srgbClr val="D1D5DB"/>
+                      </a:solidFill>
+                      <a:prstDash val="solid"/>
+                      <a:round/>
+                      <a:headEnd type="none" w="med" len="med"/>
+                      <a:tailEnd type="none" w="med" len="med"/>
+                    </a:lnB>
+                  </a:tcPr>
+                </a:tc>
+                <a:tc>
+                  <a:txBody>
+                    <a:bodyPr/>
+                    <a:lstStyle/>
+                    <a:p>
+                      <a:pPr indent="0" marL="0">
+                        <a:buNone/>
+                      </a:pPr>
+                      <a:r>
+                        <a:rPr lang="en-US" sz="1500" dirty="0">
+                          <a:solidFill>
+                            <a:srgbClr val="111827"/>
+                          </a:solidFill>
+                          <a:latin typeface="Calibri" pitchFamily="34" charset="0"/>
+                          <a:ea typeface="Calibri" pitchFamily="34" charset="-122"/>
+                          <a:cs typeface="Calibri" pitchFamily="34" charset="-120"/>
+                        </a:rPr>
+                        <a:t>POST /api/clientes (admin)</a:t>
+                      </a:r>
+                      <a:endParaRPr lang="en-US" sz="1500" dirty="0">
+                        <a:latin typeface="Calibri" charset="0"/>
+                        <a:ea typeface="Calibri" charset="0"/>
+                        <a:cs typeface="Calibri" charset="0"/>
+                      </a:endParaRPr>
+                    </a:p>
+                  </a:txBody>
+                  <a:tcPr marL="109728" marR="109728" marT="54864" marB="54864" anchor="ctr">
+                    <a:lnL w="9525" cap="flat" cmpd="sng" algn="ctr">
+                      <a:solidFill>
+                        <a:srgbClr val="D1D5DB"/>
+                      </a:solidFill>
+                      <a:prstDash val="solid"/>
+                      <a:round/>
+                      <a:headEnd type="none" w="med" len="med"/>
+                      <a:tailEnd type="none" w="med" len="med"/>
+                    </a:lnL>
+                    <a:lnR w="9525" cap="flat" cmpd="sng" algn="ctr">
+                      <a:solidFill>
+                        <a:srgbClr val="D1D5DB"/>
+                      </a:solidFill>
+                      <a:prstDash val="solid"/>
+                      <a:round/>
+                      <a:headEnd type="none" w="med" len="med"/>
+                      <a:tailEnd type="none" w="med" len="med"/>
+                    </a:lnR>
+                    <a:lnT w="9525" cap="flat" cmpd="sng" algn="ctr">
+                      <a:solidFill>
+                        <a:srgbClr val="D1D5DB"/>
+                      </a:solidFill>
+                      <a:prstDash val="solid"/>
+                      <a:round/>
+                      <a:headEnd type="none" w="med" len="med"/>
+                      <a:tailEnd type="none" w="med" len="med"/>
+                    </a:lnT>
+                    <a:lnB w="9525" cap="flat" cmpd="sng" algn="ctr">
+                      <a:solidFill>
+                        <a:srgbClr val="D1D5DB"/>
+                      </a:solidFill>
+                      <a:prstDash val="solid"/>
+                      <a:round/>
+                      <a:headEnd type="none" w="med" len="med"/>
+                      <a:tailEnd type="none" w="med" len="med"/>
+                    </a:lnB>
+                  </a:tcPr>
+                </a:tc>
+                <a:tc>
+                  <a:txBody>
+                    <a:bodyPr/>
+                    <a:lstStyle/>
+                    <a:p>
+                      <a:pPr indent="0" marL="0">
+                        <a:buNone/>
+                      </a:pPr>
+                      <a:r>
+                        <a:rPr lang="en-US" sz="1500" dirty="0">
+                          <a:solidFill>
+                            <a:srgbClr val="111827"/>
+                          </a:solidFill>
+                          <a:latin typeface="Calibri" pitchFamily="34" charset="0"/>
+                          <a:ea typeface="Calibri" pitchFamily="34" charset="-122"/>
+                          <a:cs typeface="Calibri" pitchFamily="34" charset="-120"/>
+                        </a:rPr>
+                        <a:t>GET /api/clientes/{id}</a:t>
+                      </a:r>
+                      <a:endParaRPr lang="en-US" sz="1500" dirty="0">
+                        <a:latin typeface="Calibri" charset="0"/>
+                        <a:ea typeface="Calibri" charset="0"/>
+                        <a:cs typeface="Calibri" charset="0"/>
+                      </a:endParaRPr>
+                    </a:p>
+                  </a:txBody>
+                  <a:tcPr marL="109728" marR="109728" marT="54864" marB="54864" anchor="ctr">
+                    <a:lnL w="9525" cap="flat" cmpd="sng" algn="ctr">
+                      <a:solidFill>
+                        <a:srgbClr val="D1D5DB"/>
+                      </a:solidFill>
+                      <a:prstDash val="solid"/>
+                      <a:round/>
+                      <a:headEnd type="none" w="med" len="med"/>
+                      <a:tailEnd type="none" w="med" len="med"/>
+                    </a:lnL>
+                    <a:lnR w="9525" cap="flat" cmpd="sng" algn="ctr">
+                      <a:solidFill>
+                        <a:srgbClr val="D1D5DB"/>
+                      </a:solidFill>
+                      <a:prstDash val="solid"/>
+                      <a:round/>
+                      <a:headEnd type="none" w="med" len="med"/>
+                      <a:tailEnd type="none" w="med" len="med"/>
+                    </a:lnR>
+                    <a:lnT w="9525" cap="flat" cmpd="sng" algn="ctr">
+                      <a:solidFill>
+                        <a:srgbClr val="D1D5DB"/>
+                      </a:solidFill>
+                      <a:prstDash val="solid"/>
+                      <a:round/>
+                      <a:headEnd type="none" w="med" len="med"/>
+                      <a:tailEnd type="none" w="med" len="med"/>
+                    </a:lnT>
+                    <a:lnB w="9525" cap="flat" cmpd="sng" algn="ctr">
+                      <a:solidFill>
+                        <a:srgbClr val="D1D5DB"/>
+                      </a:solidFill>
+                      <a:prstDash val="solid"/>
+                      <a:round/>
+                      <a:headEnd type="none" w="med" len="med"/>
+                      <a:tailEnd type="none" w="med" len="med"/>
+                    </a:lnB>
+                  </a:tcPr>
+                </a:tc>
+                <a:tc>
+                  <a:txBody>
+                    <a:bodyPr/>
+                    <a:lstStyle/>
+                    <a:p>
+                      <a:pPr indent="0" marL="0">
+                        <a:buNone/>
+                      </a:pPr>
+                      <a:r>
+                        <a:rPr lang="en-US" sz="1500" dirty="0">
+                          <a:solidFill>
+                            <a:srgbClr val="111827"/>
+                          </a:solidFill>
+                          <a:latin typeface="Calibri" pitchFamily="34" charset="0"/>
+                          <a:ea typeface="Calibri" pitchFamily="34" charset="-122"/>
+                          <a:cs typeface="Calibri" pitchFamily="34" charset="-120"/>
+                        </a:rPr>
+                        <a:t>PUT (quien ve al cliente); DELETE solo sin cuentas</a:t>
+                      </a:r>
+                      <a:endParaRPr lang="en-US" sz="1500" dirty="0">
+                        <a:latin typeface="Calibri" charset="0"/>
+                        <a:ea typeface="Calibri" charset="0"/>
+                        <a:cs typeface="Calibri" charset="0"/>
+                      </a:endParaRPr>
+                    </a:p>
+                  </a:txBody>
+                  <a:tcPr marL="109728" marR="109728" marT="54864" marB="54864" anchor="ctr">
+                    <a:lnL w="9525" cap="flat" cmpd="sng" algn="ctr">
+                      <a:solidFill>
+                        <a:srgbClr val="D1D5DB"/>
+                      </a:solidFill>
+                      <a:prstDash val="solid"/>
+                      <a:round/>
+                      <a:headEnd type="none" w="med" len="med"/>
+                      <a:tailEnd type="none" w="med" len="med"/>
+                    </a:lnL>
+                    <a:lnR w="9525" cap="flat" cmpd="sng" algn="ctr">
+                      <a:solidFill>
+                        <a:srgbClr val="D1D5DB"/>
+                      </a:solidFill>
+                      <a:prstDash val="solid"/>
+                      <a:round/>
+                      <a:headEnd type="none" w="med" len="med"/>
+                      <a:tailEnd type="none" w="med" len="med"/>
+                    </a:lnR>
+                    <a:lnT w="9525" cap="flat" cmpd="sng" algn="ctr">
+                      <a:solidFill>
+                        <a:srgbClr val="D1D5DB"/>
+                      </a:solidFill>
+                      <a:prstDash val="solid"/>
+                      <a:round/>
+                      <a:headEnd type="none" w="med" len="med"/>
+                      <a:tailEnd type="none" w="med" len="med"/>
+                    </a:lnT>
+                    <a:lnB w="9525" cap="flat" cmpd="sng" algn="ctr">
+                      <a:solidFill>
+                        <a:srgbClr val="D1D5DB"/>
+                      </a:solidFill>
+                      <a:prstDash val="solid"/>
+                      <a:round/>
+                      <a:headEnd type="none" w="med" len="med"/>
+                      <a:tailEnd type="none" w="med" len="med"/>
+                    </a:lnB>
+                  </a:tcPr>
+                </a:tc>
+              </a:tr>
+              <a:tr h="512064">
                 <a:tc>
                   <a:txBody>
                     <a:bodyPr/>
@@ -6261,7 +6544,7 @@
                   </a:tcPr>
                 </a:tc>
               </a:tr>
-              <a:tr h="566928">
+              <a:tr h="512064">
                 <a:tc>
                   <a:txBody>
                     <a:bodyPr/>
@@ -6523,7 +6806,7 @@
                   </a:tcPr>
                 </a:tc>
               </a:tr>
-              <a:tr h="566928">
+              <a:tr h="512064">
                 <a:tc>
                   <a:txBody>
                     <a:bodyPr/>
@@ -6797,8 +7080,8 @@
         </p:nvSpPr>
         <p:spPr>
           <a:xfrm>
-            <a:off x="548640" y="5394960"/>
-            <a:ext cx="11064240" cy="640080"/>
+            <a:off x="548640" y="5715000"/>
+            <a:ext cx="11064240" cy="548640"/>
           </a:xfrm>
           <a:prstGeom prst="rect">
             <a:avLst/>
@@ -6822,7 +7105,7 @@
                 <a:ea typeface="Calibri" pitchFamily="34" charset="-122"/>
                 <a:cs typeface="Calibri" pitchFamily="34" charset="-120"/>
               </a:rPr>
-              <a:t>El CRUD completo se cumple en usuarios y tipificaciones. Los demás registros se crean por el flujo de negocio y no se borran físicamente, para conservar la trazabilidad.</a:t>
+              <a:t>El CRUD completo se cumple en clientes y tipificaciones. Usuarios se da de baja desactivándolo. Gestiones, promesas, cuentas y pagos se crean por el flujo de negocio y no se borran, para conservar la trazabilidad.</a:t>
             </a:r>
             <a:endParaRPr lang="en-US" sz="1500" dirty="0"/>
           </a:p>
@@ -7916,7 +8199,7 @@
                 <a:ea typeface="Calibri" pitchFamily="34" charset="-122"/>
                 <a:cs typeface="Calibri" pitchFamily="34" charset="-120"/>
               </a:rPr>
-              <a:t>Pruebas automáticas: 7 de 7 pasan</a:t>
+              <a:t>Pruebas automáticas: 9 de 9 pasan</a:t>
             </a:r>
             <a:endParaRPr lang="en-US" sz="3200" dirty="0"/>
           </a:p>
@@ -8021,7 +8304,7 @@
                 <a:ea typeface="Calibri" pitchFamily="34" charset="-122"/>
                 <a:cs typeface="Calibri" pitchFamily="34" charset="-120"/>
               </a:rPr>
-              <a:t>7 / 7</a:t>
+              <a:t>9 / 9</a:t>
             </a:r>
             <a:endParaRPr lang="en-US" sz="6000" dirty="0"/>
           </a:p>
@@ -8075,7 +8358,7 @@
         <p:spPr>
           <a:xfrm>
             <a:off x="4297680" y="1828800"/>
-            <a:ext cx="7315200" cy="3291840"/>
+            <a:ext cx="7315200" cy="3474720"/>
           </a:xfrm>
           <a:prstGeom prst="rect">
             <a:avLst/>
@@ -8089,14 +8372,14 @@
           <a:p>
             <a:pPr marL="342900" indent="-342900">
               <a:spcAft>
-                <a:spcPts val="800"/>
+                <a:spcPts val="500"/>
               </a:spcAft>
               <a:buSzPct val="100000"/>
               <a:buFont typeface="+mj-lt"/>
               <a:buAutoNum type="arabicPeriod" startAt="1"/>
             </a:pPr>
             <a:r>
-              <a:rPr lang="en-US" sz="1800" dirty="0">
+              <a:rPr lang="en-US" sz="1600" dirty="0">
                 <a:solidFill>
                   <a:srgbClr val="111827"/>
                 </a:solidFill>
@@ -8106,19 +8389,19 @@
               </a:rPr>
               <a:t>Login correcto y 401 sin token (RF01)</a:t>
             </a:r>
-            <a:endParaRPr lang="en-US" sz="1800" dirty="0"/>
+            <a:endParaRPr lang="en-US" sz="1600" dirty="0"/>
           </a:p>
           <a:p>
             <a:pPr marL="342900" indent="-342900">
               <a:spcAft>
-                <a:spcPts val="800"/>
+                <a:spcPts val="500"/>
               </a:spcAft>
               <a:buSzPct val="100000"/>
               <a:buFont typeface="+mj-lt"/>
               <a:buAutoNum type="arabicPeriod" startAt="1"/>
             </a:pPr>
             <a:r>
-              <a:rPr lang="en-US" sz="1800" dirty="0">
+              <a:rPr lang="en-US" sz="1600" dirty="0">
                 <a:solidFill>
                   <a:srgbClr val="111827"/>
                 </a:solidFill>
@@ -8128,19 +8411,19 @@
               </a:rPr>
               <a:t>Permisos por rol: 403 al asesor (RNF05)</a:t>
             </a:r>
-            <a:endParaRPr lang="en-US" sz="1800" dirty="0"/>
+            <a:endParaRPr lang="en-US" sz="1600" dirty="0"/>
           </a:p>
           <a:p>
             <a:pPr marL="342900" indent="-342900">
               <a:spcAft>
-                <a:spcPts val="800"/>
+                <a:spcPts val="500"/>
               </a:spcAft>
               <a:buSzPct val="100000"/>
               <a:buFont typeface="+mj-lt"/>
               <a:buAutoNum type="arabicPeriod" startAt="1"/>
             </a:pPr>
             <a:r>
-              <a:rPr lang="en-US" sz="1800" dirty="0">
+              <a:rPr lang="en-US" sz="1600" dirty="0">
                 <a:solidFill>
                   <a:srgbClr val="111827"/>
                 </a:solidFill>
@@ -8150,19 +8433,19 @@
               </a:rPr>
               <a:t>Asesor solo ve su cartera (RF03, RF04)</a:t>
             </a:r>
-            <a:endParaRPr lang="en-US" sz="1800" dirty="0"/>
+            <a:endParaRPr lang="en-US" sz="1600" dirty="0"/>
           </a:p>
           <a:p>
             <a:pPr marL="342900" indent="-342900">
               <a:spcAft>
-                <a:spcPts val="800"/>
+                <a:spcPts val="500"/>
               </a:spcAft>
               <a:buSzPct val="100000"/>
               <a:buFont typeface="+mj-lt"/>
               <a:buAutoNum type="arabicPeriod" startAt="1"/>
             </a:pPr>
             <a:r>
-              <a:rPr lang="en-US" sz="1800" dirty="0">
+              <a:rPr lang="en-US" sz="1600" dirty="0">
                 <a:solidFill>
                   <a:srgbClr val="111827"/>
                 </a:solidFill>
@@ -8172,19 +8455,19 @@
               </a:rPr>
               <a:t>Gestión con promesa y pagos duplicados (RF07, RF08, RF21)</a:t>
             </a:r>
-            <a:endParaRPr lang="en-US" sz="1800" dirty="0"/>
+            <a:endParaRPr lang="en-US" sz="1600" dirty="0"/>
           </a:p>
           <a:p>
             <a:pPr marL="342900" indent="-342900">
               <a:spcAft>
-                <a:spcPts val="800"/>
+                <a:spcPts val="500"/>
               </a:spcAft>
               <a:buSzPct val="100000"/>
               <a:buFont typeface="+mj-lt"/>
               <a:buAutoNum type="arabicPeriod" startAt="1"/>
             </a:pPr>
             <a:r>
-              <a:rPr lang="en-US" sz="1800" dirty="0">
+              <a:rPr lang="en-US" sz="1600" dirty="0">
                 <a:solidFill>
                   <a:srgbClr val="111827"/>
                 </a:solidFill>
@@ -8194,19 +8477,19 @@
               </a:rPr>
               <a:t>Carga de asignaciones válida e inválida (RF19, RF21)</a:t>
             </a:r>
-            <a:endParaRPr lang="en-US" sz="1800" dirty="0"/>
+            <a:endParaRPr lang="en-US" sz="1600" dirty="0"/>
           </a:p>
           <a:p>
             <a:pPr marL="342900" indent="-342900">
               <a:spcAft>
-                <a:spcPts val="800"/>
+                <a:spcPts val="500"/>
               </a:spcAft>
               <a:buSzPct val="100000"/>
               <a:buFont typeface="+mj-lt"/>
               <a:buAutoNum type="arabicPeriod" startAt="1"/>
             </a:pPr>
             <a:r>
-              <a:rPr lang="en-US" sz="1800" dirty="0">
+              <a:rPr lang="en-US" sz="1600" dirty="0">
                 <a:solidFill>
                   <a:srgbClr val="111827"/>
                 </a:solidFill>
@@ -8216,19 +8499,19 @@
               </a:rPr>
               <a:t>Supervisor solo administra su equipo (RF16)</a:t>
             </a:r>
-            <a:endParaRPr lang="en-US" sz="1800" dirty="0"/>
+            <a:endParaRPr lang="en-US" sz="1600" dirty="0"/>
           </a:p>
           <a:p>
             <a:pPr marL="342900" indent="-342900">
               <a:spcAft>
-                <a:spcPts val="800"/>
+                <a:spcPts val="500"/>
               </a:spcAft>
               <a:buSzPct val="100000"/>
               <a:buFont typeface="+mj-lt"/>
               <a:buAutoNum type="arabicPeriod" startAt="1"/>
             </a:pPr>
             <a:r>
-              <a:rPr lang="en-US" sz="1800" dirty="0">
+              <a:rPr lang="en-US" sz="1600" dirty="0">
                 <a:solidFill>
                   <a:srgbClr val="111827"/>
                 </a:solidFill>
@@ -8238,7 +8521,51 @@
               </a:rPr>
               <a:t>Tipificaciones se desactivan sin borrarse (RF22)</a:t>
             </a:r>
-            <a:endParaRPr lang="en-US" sz="1800" dirty="0"/>
+            <a:endParaRPr lang="en-US" sz="1600" dirty="0"/>
+          </a:p>
+          <a:p>
+            <a:pPr marL="342900" indent="-342900">
+              <a:spcAft>
+                <a:spcPts val="500"/>
+              </a:spcAft>
+              <a:buSzPct val="100000"/>
+              <a:buFont typeface="+mj-lt"/>
+              <a:buAutoNum type="arabicPeriod" startAt="1"/>
+            </a:pPr>
+            <a:r>
+              <a:rPr lang="en-US" sz="1600" dirty="0">
+                <a:solidFill>
+                  <a:srgbClr val="111827"/>
+                </a:solidFill>
+                <a:latin typeface="Calibri" pitchFamily="34" charset="0"/>
+                <a:ea typeface="Calibri" pitchFamily="34" charset="-122"/>
+                <a:cs typeface="Calibri" pitchFamily="34" charset="-120"/>
+              </a:rPr>
+              <a:t>CRUD de clientes: solo el admin crea y elimina; el asesor edita su cartera</a:t>
+            </a:r>
+            <a:endParaRPr lang="en-US" sz="1600" dirty="0"/>
+          </a:p>
+          <a:p>
+            <a:pPr marL="342900" indent="-342900">
+              <a:spcAft>
+                <a:spcPts val="500"/>
+              </a:spcAft>
+              <a:buSzPct val="100000"/>
+              <a:buFont typeface="+mj-lt"/>
+              <a:buAutoNum type="arabicPeriod" startAt="1"/>
+            </a:pPr>
+            <a:r>
+              <a:rPr lang="en-US" sz="1600" dirty="0">
+                <a:solidFill>
+                  <a:srgbClr val="111827"/>
+                </a:solidFill>
+                <a:latin typeface="Calibri" pitchFamily="34" charset="0"/>
+                <a:ea typeface="Calibri" pitchFamily="34" charset="-122"/>
+                <a:cs typeface="Calibri" pitchFamily="34" charset="-120"/>
+              </a:rPr>
+              <a:t>Carga sin archivo responde 400, no error interno</a:t>
+            </a:r>
+            <a:endParaRPr lang="en-US" sz="1600" dirty="0"/>
           </a:p>
         </p:txBody>
       </p:sp>
@@ -8275,7 +8602,7 @@
                 <a:ea typeface="Calibri" pitchFamily="34" charset="-122"/>
                 <a:cs typeface="Calibri" pitchFamily="34" charset="-120"/>
               </a:rPr>
-              <a:t>Pendiente: colección Postman (P01–P04) contra MySQL y pruebas unitarias con JUnit.</a:t>
+              <a:t>Postman: 34 de 34 peticiones pasan. Pendiente: ejecutar contra MySQL 8 real y pruebas unitarias con JUnit.</a:t>
             </a:r>
             <a:endParaRPr lang="en-US" sz="1500" dirty="0"/>
           </a:p>

</xml_diff>